<commit_message>
fix: add PNG fallback for all SVG images so PowerPoint displays them
PowerPoint requires a raster (PNG) fallback in <a:blip r:embed> when using
the svgBlip extension; decks only embedded raw SVG parts, so every icon and
chart showed 'The picture can't be displayed' in PowerPoint (LibreOffice/
Preview rendered fine, which is why it went unnoticed).

- Rasterized all 173 SVG media parts to 2-4x PNGs (resvg-js, PingFang)
- Added PNG parts + relationships; kept svgBlip extension for hi-res use
- Fixed 2 malformed SVGs with unescaped '<' in text nodes
- Affected: week-01 + week-02, both zh and en decks
</commit_message>
<xml_diff>
--- a/lectures/week-01/lecture-en.pptx
+++ b/lectures/week-01/lecture-en.pptx
@@ -3825,7 +3825,7 @@
           <p:nvPr/>
         </p:nvPicPr>
         <p:blipFill>
-          <a:blip>
+          <a:blip r:embed="rId5">
             <a:extLst>
               <a:ext uri="{96DAC541-7B7A-43D3-8B79-37D633B846F1}">
                 <asvg:svgBlip r:embed="rId1"/>
@@ -3985,7 +3985,7 @@
           <p:nvPr/>
         </p:nvPicPr>
         <p:blipFill>
-          <a:blip>
+          <a:blip r:embed="rId6">
             <a:extLst>
               <a:ext uri="{96DAC541-7B7A-43D3-8B79-37D633B846F1}">
                 <asvg:svgBlip r:embed="rId2"/>
@@ -4145,7 +4145,7 @@
           <p:nvPr/>
         </p:nvPicPr>
         <p:blipFill>
-          <a:blip>
+          <a:blip r:embed="rId4">
             <a:extLst>
               <a:ext uri="{96DAC541-7B7A-43D3-8B79-37D633B846F1}">
                 <asvg:svgBlip r:embed="rId3"/>
@@ -5373,7 +5373,7 @@
           <p:nvPr/>
         </p:nvPicPr>
         <p:blipFill>
-          <a:blip>
+          <a:blip r:embed="rId8">
             <a:extLst>
               <a:ext uri="{96DAC541-7B7A-43D3-8B79-37D633B846F1}">
                 <asvg:svgBlip r:embed="rId1"/>
@@ -5620,7 +5620,7 @@
           <p:nvPr/>
         </p:nvPicPr>
         <p:blipFill>
-          <a:blip>
+          <a:blip r:embed="rId6">
             <a:extLst>
               <a:ext uri="{96DAC541-7B7A-43D3-8B79-37D633B846F1}">
                 <asvg:svgBlip r:embed="rId2"/>
@@ -5867,7 +5867,7 @@
           <p:nvPr/>
         </p:nvPicPr>
         <p:blipFill>
-          <a:blip>
+          <a:blip r:embed="rId5">
             <a:extLst>
               <a:ext uri="{96DAC541-7B7A-43D3-8B79-37D633B846F1}">
                 <asvg:svgBlip r:embed="rId3"/>
@@ -6114,7 +6114,7 @@
           <p:nvPr/>
         </p:nvPicPr>
         <p:blipFill>
-          <a:blip>
+          <a:blip r:embed="rId7">
             <a:extLst>
               <a:ext uri="{96DAC541-7B7A-43D3-8B79-37D633B846F1}">
                 <asvg:svgBlip r:embed="rId4"/>
@@ -10469,7 +10469,7 @@
           <p:nvPr/>
         </p:nvPicPr>
         <p:blipFill>
-          <a:blip>
+          <a:blip r:embed="rId6">
             <a:extLst>
               <a:ext uri="{96DAC541-7B7A-43D3-8B79-37D633B846F1}">
                 <asvg:svgBlip r:embed="rId1"/>
@@ -10784,7 +10784,7 @@
           <p:nvPr/>
         </p:nvPicPr>
         <p:blipFill>
-          <a:blip>
+          <a:blip r:embed="rId8">
             <a:extLst>
               <a:ext uri="{96DAC541-7B7A-43D3-8B79-37D633B846F1}">
                 <asvg:svgBlip r:embed="rId2"/>
@@ -11099,7 +11099,7 @@
           <p:nvPr/>
         </p:nvPicPr>
         <p:blipFill>
-          <a:blip>
+          <a:blip r:embed="rId7">
             <a:extLst>
               <a:ext uri="{96DAC541-7B7A-43D3-8B79-37D633B846F1}">
                 <asvg:svgBlip r:embed="rId3"/>
@@ -11414,7 +11414,7 @@
           <p:nvPr/>
         </p:nvPicPr>
         <p:blipFill>
-          <a:blip>
+          <a:blip r:embed="rId5">
             <a:extLst>
               <a:ext uri="{96DAC541-7B7A-43D3-8B79-37D633B846F1}">
                 <asvg:svgBlip r:embed="rId4"/>
@@ -14230,7 +14230,7 @@
           <p:nvPr/>
         </p:nvPicPr>
         <p:blipFill>
-          <a:blip>
+          <a:blip r:embed="rId2">
             <a:extLst>
               <a:ext uri="{96DAC541-7B7A-43D3-8B79-37D633B846F1}">
                 <asvg:svgBlip r:embed="rId1"/>
@@ -14261,7 +14261,7 @@
           <p:nvPr/>
         </p:nvPicPr>
         <p:blipFill>
-          <a:blip>
+          <a:blip r:embed="rId2">
             <a:extLst>
               <a:ext uri="{96DAC541-7B7A-43D3-8B79-37D633B846F1}">
                 <asvg:svgBlip r:embed="rId1"/>
@@ -14292,7 +14292,7 @@
           <p:nvPr/>
         </p:nvPicPr>
         <p:blipFill>
-          <a:blip>
+          <a:blip r:embed="rId2">
             <a:extLst>
               <a:ext uri="{96DAC541-7B7A-43D3-8B79-37D633B846F1}">
                 <asvg:svgBlip r:embed="rId1"/>
@@ -14323,7 +14323,7 @@
           <p:nvPr/>
         </p:nvPicPr>
         <p:blipFill>
-          <a:blip>
+          <a:blip r:embed="rId2">
             <a:extLst>
               <a:ext uri="{96DAC541-7B7A-43D3-8B79-37D633B846F1}">
                 <asvg:svgBlip r:embed="rId1"/>
@@ -14354,7 +14354,7 @@
           <p:nvPr/>
         </p:nvPicPr>
         <p:blipFill>
-          <a:blip>
+          <a:blip r:embed="rId2">
             <a:extLst>
               <a:ext uri="{96DAC541-7B7A-43D3-8B79-37D633B846F1}">
                 <asvg:svgBlip r:embed="rId1"/>
@@ -14955,7 +14955,7 @@
           <p:nvPr/>
         </p:nvPicPr>
         <p:blipFill>
-          <a:blip>
+          <a:blip r:embed="rId2">
             <a:extLst>
               <a:ext uri="{96DAC541-7B7A-43D3-8B79-37D633B846F1}">
                 <asvg:svgBlip r:embed="rId1"/>
@@ -15157,7 +15157,7 @@
           <p:nvPr/>
         </p:nvPicPr>
         <p:blipFill>
-          <a:blip>
+          <a:blip r:embed="rId2">
             <a:extLst>
               <a:ext uri="{96DAC541-7B7A-43D3-8B79-37D633B846F1}">
                 <asvg:svgBlip r:embed="rId1"/>
@@ -15359,7 +15359,7 @@
           <p:nvPr/>
         </p:nvPicPr>
         <p:blipFill>
-          <a:blip>
+          <a:blip r:embed="rId2">
             <a:extLst>
               <a:ext uri="{96DAC541-7B7A-43D3-8B79-37D633B846F1}">
                 <asvg:svgBlip r:embed="rId1"/>
@@ -15561,7 +15561,7 @@
           <p:nvPr/>
         </p:nvPicPr>
         <p:blipFill>
-          <a:blip>
+          <a:blip r:embed="rId2">
             <a:extLst>
               <a:ext uri="{96DAC541-7B7A-43D3-8B79-37D633B846F1}">
                 <asvg:svgBlip r:embed="rId1"/>
@@ -15723,7 +15723,7 @@
           <p:nvPr/>
         </p:nvPicPr>
         <p:blipFill>
-          <a:blip>
+          <a:blip r:embed="rId2">
             <a:extLst>
               <a:ext uri="{96DAC541-7B7A-43D3-8B79-37D633B846F1}">
                 <asvg:svgBlip r:embed="rId1"/>
@@ -21742,7 +21742,7 @@
           <p:nvPr/>
         </p:nvPicPr>
         <p:blipFill>
-          <a:blip>
+          <a:blip r:embed="rId2">
             <a:extLst>
               <a:ext uri="{96DAC541-7B7A-43D3-8B79-37D633B846F1}">
                 <asvg:svgBlip r:embed="rId1"/>
@@ -22621,7 +22621,7 @@
           <p:nvPr/>
         </p:nvPicPr>
         <p:blipFill>
-          <a:blip>
+          <a:blip r:embed="rId2">
             <a:extLst>
               <a:ext uri="{96DAC541-7B7A-43D3-8B79-37D633B846F1}">
                 <asvg:svgBlip r:embed="rId1"/>
@@ -23727,7 +23727,7 @@
           <p:nvPr/>
         </p:nvPicPr>
         <p:blipFill>
-          <a:blip>
+          <a:blip r:embed="rId2">
             <a:extLst>
               <a:ext uri="{96DAC541-7B7A-43D3-8B79-37D633B846F1}">
                 <asvg:svgBlip r:embed="rId1"/>
@@ -23876,7 +23876,7 @@
           <p:nvPr/>
         </p:nvPicPr>
         <p:blipFill>
-          <a:blip>
+          <a:blip r:embed="rId2">
             <a:extLst>
               <a:ext uri="{96DAC541-7B7A-43D3-8B79-37D633B846F1}">
                 <asvg:svgBlip r:embed="rId1"/>
@@ -24025,7 +24025,7 @@
           <p:nvPr/>
         </p:nvPicPr>
         <p:blipFill>
-          <a:blip>
+          <a:blip r:embed="rId2">
             <a:extLst>
               <a:ext uri="{96DAC541-7B7A-43D3-8B79-37D633B846F1}">
                 <asvg:svgBlip r:embed="rId1"/>
@@ -24174,7 +24174,7 @@
           <p:nvPr/>
         </p:nvPicPr>
         <p:blipFill>
-          <a:blip>
+          <a:blip r:embed="rId2">
             <a:extLst>
               <a:ext uri="{96DAC541-7B7A-43D3-8B79-37D633B846F1}">
                 <asvg:svgBlip r:embed="rId1"/>
@@ -26174,7 +26174,7 @@
           <p:nvPr/>
         </p:nvPicPr>
         <p:blipFill>
-          <a:blip>
+          <a:blip r:embed="rId5">
             <a:extLst>
               <a:ext uri="{96DAC541-7B7A-43D3-8B79-37D633B846F1}">
                 <asvg:svgBlip r:embed="rId1"/>
@@ -26360,7 +26360,7 @@
           <p:nvPr/>
         </p:nvPicPr>
         <p:blipFill>
-          <a:blip>
+          <a:blip r:embed="rId6">
             <a:extLst>
               <a:ext uri="{96DAC541-7B7A-43D3-8B79-37D633B846F1}">
                 <asvg:svgBlip r:embed="rId2"/>
@@ -26546,7 +26546,7 @@
           <p:nvPr/>
         </p:nvPicPr>
         <p:blipFill>
-          <a:blip>
+          <a:blip r:embed="rId4">
             <a:extLst>
               <a:ext uri="{96DAC541-7B7A-43D3-8B79-37D633B846F1}">
                 <asvg:svgBlip r:embed="rId3"/>
@@ -27033,7 +27033,7 @@
           <p:nvPr/>
         </p:nvPicPr>
         <p:blipFill>
-          <a:blip>
+          <a:blip r:embed="rId4">
             <a:extLst>
               <a:ext uri="{96DAC541-7B7A-43D3-8B79-37D633B846F1}">
                 <asvg:svgBlip r:embed="rId1"/>
@@ -27523,7 +27523,7 @@
           <p:nvPr/>
         </p:nvPicPr>
         <p:blipFill>
-          <a:blip>
+          <a:blip r:embed="rId3">
             <a:extLst>
               <a:ext uri="{96DAC541-7B7A-43D3-8B79-37D633B846F1}">
                 <asvg:svgBlip r:embed="rId2"/>
@@ -28930,7 +28930,7 @@
           <p:nvPr/>
         </p:nvPicPr>
         <p:blipFill>
-          <a:blip>
+          <a:blip r:embed="rId5">
             <a:extLst>
               <a:ext uri="{96DAC541-7B7A-43D3-8B79-37D633B846F1}">
                 <asvg:svgBlip r:embed="rId1"/>
@@ -29090,7 +29090,7 @@
           <p:nvPr/>
         </p:nvPicPr>
         <p:blipFill>
-          <a:blip>
+          <a:blip r:embed="rId4">
             <a:extLst>
               <a:ext uri="{96DAC541-7B7A-43D3-8B79-37D633B846F1}">
                 <asvg:svgBlip r:embed="rId2"/>
@@ -29250,7 +29250,7 @@
           <p:nvPr/>
         </p:nvPicPr>
         <p:blipFill>
-          <a:blip>
+          <a:blip r:embed="rId6">
             <a:extLst>
               <a:ext uri="{96DAC541-7B7A-43D3-8B79-37D633B846F1}">
                 <asvg:svgBlip r:embed="rId3"/>
@@ -31681,7 +31681,7 @@
           <p:nvPr/>
         </p:nvPicPr>
         <p:blipFill>
-          <a:blip>
+          <a:blip r:embed="rId12">
             <a:extLst>
               <a:ext uri="{96DAC541-7B7A-43D3-8B79-37D633B846F1}">
                 <asvg:svgBlip r:embed="rId1"/>
@@ -31926,7 +31926,7 @@
           <p:nvPr/>
         </p:nvPicPr>
         <p:blipFill>
-          <a:blip>
+          <a:blip r:embed="rId11">
             <a:extLst>
               <a:ext uri="{96DAC541-7B7A-43D3-8B79-37D633B846F1}">
                 <asvg:svgBlip r:embed="rId2"/>
@@ -32171,7 +32171,7 @@
           <p:nvPr/>
         </p:nvPicPr>
         <p:blipFill>
-          <a:blip>
+          <a:blip r:embed="rId10">
             <a:extLst>
               <a:ext uri="{96DAC541-7B7A-43D3-8B79-37D633B846F1}">
                 <asvg:svgBlip r:embed="rId3"/>
@@ -32416,7 +32416,7 @@
           <p:nvPr/>
         </p:nvPicPr>
         <p:blipFill>
-          <a:blip>
+          <a:blip r:embed="rId8">
             <a:extLst>
               <a:ext uri="{96DAC541-7B7A-43D3-8B79-37D633B846F1}">
                 <asvg:svgBlip r:embed="rId4"/>
@@ -32661,7 +32661,7 @@
           <p:nvPr/>
         </p:nvPicPr>
         <p:blipFill>
-          <a:blip>
+          <a:blip r:embed="rId7">
             <a:extLst>
               <a:ext uri="{96DAC541-7B7A-43D3-8B79-37D633B846F1}">
                 <asvg:svgBlip r:embed="rId5"/>
@@ -33277,7 +33277,7 @@
           <p:nvPr/>
         </p:nvPicPr>
         <p:blipFill>
-          <a:blip>
+          <a:blip r:embed="rId9">
             <a:extLst>
               <a:ext uri="{96DAC541-7B7A-43D3-8B79-37D633B846F1}">
                 <asvg:svgBlip r:embed="rId6"/>
@@ -35979,7 +35979,7 @@
           <p:nvPr/>
         </p:nvPicPr>
         <p:blipFill>
-          <a:blip>
+          <a:blip r:embed="rId10">
             <a:extLst>
               <a:ext uri="{96DAC541-7B7A-43D3-8B79-37D633B846F1}">
                 <asvg:svgBlip r:embed="rId1"/>
@@ -36076,7 +36076,7 @@
           <p:nvPr/>
         </p:nvPicPr>
         <p:blipFill>
-          <a:blip>
+          <a:blip r:embed="rId10">
             <a:extLst>
               <a:ext uri="{96DAC541-7B7A-43D3-8B79-37D633B846F1}">
                 <asvg:svgBlip r:embed="rId1"/>
@@ -36173,7 +36173,7 @@
           <p:nvPr/>
         </p:nvPicPr>
         <p:blipFill>
-          <a:blip>
+          <a:blip r:embed="rId10">
             <a:extLst>
               <a:ext uri="{96DAC541-7B7A-43D3-8B79-37D633B846F1}">
                 <asvg:svgBlip r:embed="rId1"/>
@@ -36270,7 +36270,7 @@
           <p:nvPr/>
         </p:nvPicPr>
         <p:blipFill>
-          <a:blip>
+          <a:blip r:embed="rId10">
             <a:extLst>
               <a:ext uri="{96DAC541-7B7A-43D3-8B79-37D633B846F1}">
                 <asvg:svgBlip r:embed="rId1"/>
@@ -36367,7 +36367,7 @@
           <p:nvPr/>
         </p:nvPicPr>
         <p:blipFill>
-          <a:blip>
+          <a:blip r:embed="rId10">
             <a:extLst>
               <a:ext uri="{96DAC541-7B7A-43D3-8B79-37D633B846F1}">
                 <asvg:svgBlip r:embed="rId1"/>
@@ -36556,7 +36556,7 @@
           <p:nvPr/>
         </p:nvPicPr>
         <p:blipFill>
-          <a:blip>
+          <a:blip r:embed="rId9">
             <a:extLst>
               <a:ext uri="{96DAC541-7B7A-43D3-8B79-37D633B846F1}">
                 <asvg:svgBlip r:embed="rId2"/>
@@ -36688,7 +36688,7 @@
           <p:nvPr/>
         </p:nvPicPr>
         <p:blipFill>
-          <a:blip>
+          <a:blip r:embed="rId8">
             <a:extLst>
               <a:ext uri="{96DAC541-7B7A-43D3-8B79-37D633B846F1}">
                 <asvg:svgBlip r:embed="rId3"/>
@@ -36820,7 +36820,7 @@
           <p:nvPr/>
         </p:nvPicPr>
         <p:blipFill>
-          <a:blip>
+          <a:blip r:embed="rId7">
             <a:extLst>
               <a:ext uri="{96DAC541-7B7A-43D3-8B79-37D633B846F1}">
                 <asvg:svgBlip r:embed="rId4"/>
@@ -36952,7 +36952,7 @@
           <p:nvPr/>
         </p:nvPicPr>
         <p:blipFill>
-          <a:blip>
+          <a:blip r:embed="rId6">
             <a:extLst>
               <a:ext uri="{96DAC541-7B7A-43D3-8B79-37D633B846F1}">
                 <asvg:svgBlip r:embed="rId5"/>
@@ -45303,7 +45303,7 @@
           <p:nvPr/>
         </p:nvPicPr>
         <p:blipFill>
-          <a:blip>
+          <a:blip r:embed="rId6">
             <a:extLst>
               <a:ext uri="{96DAC541-7B7A-43D3-8B79-37D633B846F1}">
                 <asvg:svgBlip r:embed="rId1"/>
@@ -45437,7 +45437,7 @@
           <p:nvPr/>
         </p:nvPicPr>
         <p:blipFill>
-          <a:blip>
+          <a:blip r:embed="rId8">
             <a:extLst>
               <a:ext uri="{96DAC541-7B7A-43D3-8B79-37D633B846F1}">
                 <asvg:svgBlip r:embed="rId2"/>
@@ -45569,7 +45569,7 @@
           <p:nvPr/>
         </p:nvPicPr>
         <p:blipFill>
-          <a:blip>
+          <a:blip r:embed="rId5">
             <a:extLst>
               <a:ext uri="{96DAC541-7B7A-43D3-8B79-37D633B846F1}">
                 <asvg:svgBlip r:embed="rId3"/>
@@ -45703,7 +45703,7 @@
           <p:nvPr/>
         </p:nvPicPr>
         <p:blipFill>
-          <a:blip>
+          <a:blip r:embed="rId7">
             <a:extLst>
               <a:ext uri="{96DAC541-7B7A-43D3-8B79-37D633B846F1}">
                 <asvg:svgBlip r:embed="rId4"/>
@@ -47415,7 +47415,7 @@
           <p:nvPr/>
         </p:nvPicPr>
         <p:blipFill>
-          <a:blip>
+          <a:blip r:embed="rId2">
             <a:extLst>
               <a:ext uri="{96DAC541-7B7A-43D3-8B79-37D633B846F1}">
                 <asvg:svgBlip r:embed="rId1"/>
@@ -47767,7 +47767,7 @@
           <p:nvPr/>
         </p:nvPicPr>
         <p:blipFill>
-          <a:blip>
+          <a:blip r:embed="rId6">
             <a:extLst>
               <a:ext uri="{96DAC541-7B7A-43D3-8B79-37D633B846F1}">
                 <asvg:svgBlip r:embed="rId1"/>
@@ -48250,7 +48250,7 @@
           <p:nvPr/>
         </p:nvPicPr>
         <p:blipFill>
-          <a:blip>
+          <a:blip r:embed="rId5">
             <a:extLst>
               <a:ext uri="{96DAC541-7B7A-43D3-8B79-37D633B846F1}">
                 <asvg:svgBlip r:embed="rId2"/>
@@ -48740,7 +48740,7 @@
           <p:nvPr/>
         </p:nvPicPr>
         <p:blipFill>
-          <a:blip>
+          <a:blip r:embed="rId8">
             <a:extLst>
               <a:ext uri="{96DAC541-7B7A-43D3-8B79-37D633B846F1}">
                 <asvg:svgBlip r:embed="rId3"/>
@@ -49152,7 +49152,7 @@
           <p:nvPr/>
         </p:nvPicPr>
         <p:blipFill>
-          <a:blip>
+          <a:blip r:embed="rId7">
             <a:extLst>
               <a:ext uri="{96DAC541-7B7A-43D3-8B79-37D633B846F1}">
                 <asvg:svgBlip r:embed="rId4"/>

</xml_diff>